<commit_message>
Six defects, not five: add the fabricated-data finding to the deck
The sixth defect belongs on that slide more than any of the other five. It is
not a code bug - it is a data-integrity failure, and it is the one that connects
back to the honesty principle the whole project rests on. Placed last so the
slide ends there.

Deck slide retimed to six rows and rebuilt; PDF refreshed. The demo script's
delivery notes now say to tell the first and the last and let the slide carry
the middle four, and the README's summary line follows.

The argument closes differently with it in: not "I believe in provenance
discipline" but "I caught myself shipping invented data labelled as published,
and then built the boundary that makes it visible."

Co-Authored-By: Claude Opus 5 <noreply@anthropic.com>
</commit_message>
<xml_diff>
--- a/docs/deck/ai_to_lab_orchestrator.pptx
+++ b/docs/deck/ai_to_lab_orchestrator.pptx
@@ -1999,7 +1999,7 @@
           <a:p>
             <a:r>
               <a:rPr lang="en-US" dirty="0"/>
-              <a:t>This is the slide that separates me from a candidate who only shows what worked. The pattern across all five is the same: the failure mode that matters is the silent one, where the system looks right and is not.</a:t>
+              <a:t>This is the slide that separates me from a candidate who only shows what worked. The pattern across all six is the same: the failure mode that matters is the silent one, where the system looks right and is not. If time is short, tell 01 and 06 and let the slide carry the rest — 06 is the one that connects back to the honesty principle the whole project rests on.</a:t>
             </a:r>
             <a:endParaRPr lang="en-US" dirty="0"/>
           </a:p>
@@ -8358,7 +8358,7 @@
                 <a:ea typeface="Cambria" pitchFamily="34" charset="-122"/>
                 <a:cs typeface="Cambria" pitchFamily="34" charset="-120"/>
               </a:rPr>
-              <a:t>Five defects I found in my own build</a:t>
+              <a:t>Six defects I found in my own build</a:t>
             </a:r>
             <a:endParaRPr lang="en-US" sz="3400" dirty="0"/>
           </a:p>
@@ -8400,7 +8400,7 @@
                 <a:ea typeface="Calibri" pitchFamily="34" charset="-122"/>
                 <a:cs typeface="Calibri" pitchFamily="34" charset="-120"/>
               </a:rPr>
-              <a:t>These are real, not hypotheticals, and they are documented in the repository. Four of the five were silent — the system looked correct while being wrong.</a:t>
+              <a:t>These are real, not hypotheticals, and they are documented in the repository. Five of the six were silent — the system looked correct while being wrong.</a:t>
             </a:r>
             <a:endParaRPr lang="en-US" sz="1450" dirty="0"/>
           </a:p>
@@ -8414,7 +8414,7 @@
         </p:nvSpPr>
         <p:spPr>
           <a:xfrm>
-            <a:off x="566928" y="2212848"/>
+            <a:off x="566928" y="2157984"/>
             <a:ext cx="457200" cy="274320"/>
           </a:xfrm>
           <a:prstGeom prst="rect">
@@ -8431,7 +8431,7 @@
               <a:buNone/>
             </a:pPr>
             <a:r>
-              <a:rPr lang="en-US" sz="1200" b="1" dirty="0">
+              <a:rPr lang="en-US" sz="1150" b="1" dirty="0">
                 <a:solidFill>
                   <a:srgbClr val="C2410C"/>
                 </a:solidFill>
@@ -8441,7 +8441,7 @@
               </a:rPr>
               <a:t>01</a:t>
             </a:r>
-            <a:endParaRPr lang="en-US" sz="1200" dirty="0"/>
+            <a:endParaRPr lang="en-US" sz="1150" dirty="0"/>
           </a:p>
         </p:txBody>
       </p:sp>
@@ -8453,7 +8453,7 @@
         </p:nvSpPr>
         <p:spPr>
           <a:xfrm>
-            <a:off x="1069848" y="2212848"/>
+            <a:off x="1069848" y="2157984"/>
             <a:ext cx="3200400" cy="274320"/>
           </a:xfrm>
           <a:prstGeom prst="rect">
@@ -8470,7 +8470,7 @@
               <a:buNone/>
             </a:pPr>
             <a:r>
-              <a:rPr lang="en-US" sz="1350" b="1" dirty="0">
+              <a:rPr lang="en-US" sz="1250" b="1" dirty="0">
                 <a:solidFill>
                   <a:srgbClr val="FFFFFF"/>
                 </a:solidFill>
@@ -8480,7 +8480,7 @@
               </a:rPr>
               <a:t>The safety gate protected nothing</a:t>
             </a:r>
-            <a:endParaRPr lang="en-US" sz="1350" dirty="0"/>
+            <a:endParaRPr lang="en-US" sz="1250" dirty="0"/>
           </a:p>
         </p:txBody>
       </p:sp>
@@ -8492,8 +8492,8 @@
         </p:nvSpPr>
         <p:spPr>
           <a:xfrm>
-            <a:off x="4361688" y="2176272"/>
-            <a:ext cx="3474720" cy="822960"/>
+            <a:off x="4361688" y="2121408"/>
+            <a:ext cx="3474720" cy="713232"/>
           </a:xfrm>
           <a:prstGeom prst="rect">
             <a:avLst/>
@@ -8507,12 +8507,12 @@
           <a:p>
             <a:pPr indent="0" marL="0">
               <a:lnSpc>
-                <a:spcPts val="1250"/>
+                <a:spcPts val="1200"/>
               </a:lnSpc>
               <a:buNone/>
             </a:pPr>
             <a:r>
-              <a:rPr lang="en-US" sz="950" dirty="0">
+              <a:rPr lang="en-US" sz="900" dirty="0">
                 <a:solidFill>
                   <a:srgbClr val="9CACBA"/>
                 </a:solidFill>
@@ -8522,7 +8522,7 @@
               </a:rPr>
               <a:t>Its hazard region was a strict subset of the true failure region, so every experiment it flagged was already doomed. It prevented zero damage while appearing to work in every demo.</a:t>
             </a:r>
-            <a:endParaRPr lang="en-US" sz="950" dirty="0"/>
+            <a:endParaRPr lang="en-US" sz="900" dirty="0"/>
           </a:p>
         </p:txBody>
       </p:sp>
@@ -8534,8 +8534,8 @@
         </p:nvSpPr>
         <p:spPr>
           <a:xfrm>
-            <a:off x="8138160" y="2176272"/>
-            <a:ext cx="3474720" cy="822960"/>
+            <a:off x="8138160" y="2121408"/>
+            <a:ext cx="3474720" cy="713232"/>
           </a:xfrm>
           <a:prstGeom prst="rect">
             <a:avLst/>
@@ -8549,12 +8549,12 @@
           <a:p>
             <a:pPr indent="0" marL="0">
               <a:lnSpc>
-                <a:spcPts val="1250"/>
+                <a:spcPts val="1200"/>
               </a:lnSpc>
               <a:buNone/>
             </a:pPr>
             <a:r>
-              <a:rPr lang="en-US" sz="950" i="1" dirty="0">
+              <a:rPr lang="en-US" sz="900" i="1" dirty="0">
                 <a:solidFill>
                   <a:srgbClr val="6FA8CE"/>
                 </a:solidFill>
@@ -8564,7 +8564,7 @@
               </a:rPr>
               <a:t>Governance fails identically to how it succeeds. It needs a test, not a demo.</a:t>
             </a:r>
-            <a:endParaRPr lang="en-US" sz="950" dirty="0"/>
+            <a:endParaRPr lang="en-US" sz="900" dirty="0"/>
           </a:p>
         </p:txBody>
       </p:sp>
@@ -8576,7 +8576,7 @@
         </p:nvSpPr>
         <p:spPr>
           <a:xfrm>
-            <a:off x="566928" y="3081528"/>
+            <a:off x="566928" y="2898648"/>
             <a:ext cx="457200" cy="274320"/>
           </a:xfrm>
           <a:prstGeom prst="rect">
@@ -8593,7 +8593,7 @@
               <a:buNone/>
             </a:pPr>
             <a:r>
-              <a:rPr lang="en-US" sz="1200" b="1" dirty="0">
+              <a:rPr lang="en-US" sz="1150" b="1" dirty="0">
                 <a:solidFill>
                   <a:srgbClr val="C2410C"/>
                 </a:solidFill>
@@ -8603,7 +8603,7 @@
               </a:rPr>
               <a:t>02</a:t>
             </a:r>
-            <a:endParaRPr lang="en-US" sz="1200" dirty="0"/>
+            <a:endParaRPr lang="en-US" sz="1150" dirty="0"/>
           </a:p>
         </p:txBody>
       </p:sp>
@@ -8615,7 +8615,7 @@
         </p:nvSpPr>
         <p:spPr>
           <a:xfrm>
-            <a:off x="1069848" y="3081528"/>
+            <a:off x="1069848" y="2898648"/>
             <a:ext cx="3200400" cy="274320"/>
           </a:xfrm>
           <a:prstGeom prst="rect">
@@ -8632,7 +8632,7 @@
               <a:buNone/>
             </a:pPr>
             <a:r>
-              <a:rPr lang="en-US" sz="1350" b="1" dirty="0">
+              <a:rPr lang="en-US" sz="1250" b="1" dirty="0">
                 <a:solidFill>
                   <a:srgbClr val="FFFFFF"/>
                 </a:solidFill>
@@ -8642,7 +8642,7 @@
               </a:rPr>
               <a:t>The benchmark numbers were wrong</a:t>
             </a:r>
-            <a:endParaRPr lang="en-US" sz="1350" dirty="0"/>
+            <a:endParaRPr lang="en-US" sz="1250" dirty="0"/>
           </a:p>
         </p:txBody>
       </p:sp>
@@ -8654,8 +8654,8 @@
         </p:nvSpPr>
         <p:spPr>
           <a:xfrm>
-            <a:off x="4361688" y="3044952"/>
-            <a:ext cx="3474720" cy="822960"/>
+            <a:off x="4361688" y="2862072"/>
+            <a:ext cx="3474720" cy="713232"/>
           </a:xfrm>
           <a:prstGeom prst="rect">
             <a:avLst/>
@@ -8669,12 +8669,12 @@
           <a:p>
             <a:pPr indent="0" marL="0">
               <a:lnSpc>
-                <a:spcPts val="1250"/>
+                <a:spcPts val="1200"/>
               </a:lnSpc>
               <a:buNone/>
             </a:pPr>
             <a:r>
-              <a:rPr lang="en-US" sz="950" dirty="0">
+              <a:rPr lang="en-US" sz="900" dirty="0">
                 <a:solidFill>
                   <a:srgbClr val="9CACBA"/>
                 </a:solidFill>
@@ -8684,7 +8684,7 @@
               </a:rPr>
               <a:t>The README claimed a BO median of 0.84. The measured value was 0.806, and no script in the repository produced either number.</a:t>
             </a:r>
-            <a:endParaRPr lang="en-US" sz="950" dirty="0"/>
+            <a:endParaRPr lang="en-US" sz="900" dirty="0"/>
           </a:p>
         </p:txBody>
       </p:sp>
@@ -8696,8 +8696,8 @@
         </p:nvSpPr>
         <p:spPr>
           <a:xfrm>
-            <a:off x="8138160" y="3044952"/>
-            <a:ext cx="3474720" cy="822960"/>
+            <a:off x="8138160" y="2862072"/>
+            <a:ext cx="3474720" cy="713232"/>
           </a:xfrm>
           <a:prstGeom prst="rect">
             <a:avLst/>
@@ -8711,12 +8711,12 @@
           <a:p>
             <a:pPr indent="0" marL="0">
               <a:lnSpc>
-                <a:spcPts val="1250"/>
+                <a:spcPts val="1200"/>
               </a:lnSpc>
               <a:buNone/>
             </a:pPr>
             <a:r>
-              <a:rPr lang="en-US" sz="950" i="1" dirty="0">
+              <a:rPr lang="en-US" sz="900" i="1" dirty="0">
                 <a:solidFill>
                   <a:srgbClr val="6FA8CE"/>
                 </a:solidFill>
@@ -8726,7 +8726,7 @@
               </a:rPr>
               <a:t>One script is now the sole source of every published figure.</a:t>
             </a:r>
-            <a:endParaRPr lang="en-US" sz="950" dirty="0"/>
+            <a:endParaRPr lang="en-US" sz="900" dirty="0"/>
           </a:p>
         </p:txBody>
       </p:sp>
@@ -8738,7 +8738,7 @@
         </p:nvSpPr>
         <p:spPr>
           <a:xfrm>
-            <a:off x="566928" y="3950208"/>
+            <a:off x="566928" y="3639312"/>
             <a:ext cx="457200" cy="274320"/>
           </a:xfrm>
           <a:prstGeom prst="rect">
@@ -8755,7 +8755,7 @@
               <a:buNone/>
             </a:pPr>
             <a:r>
-              <a:rPr lang="en-US" sz="1200" b="1" dirty="0">
+              <a:rPr lang="en-US" sz="1150" b="1" dirty="0">
                 <a:solidFill>
                   <a:srgbClr val="C2410C"/>
                 </a:solidFill>
@@ -8765,7 +8765,7 @@
               </a:rPr>
               <a:t>03</a:t>
             </a:r>
-            <a:endParaRPr lang="en-US" sz="1200" dirty="0"/>
+            <a:endParaRPr lang="en-US" sz="1150" dirty="0"/>
           </a:p>
         </p:txBody>
       </p:sp>
@@ -8777,7 +8777,7 @@
         </p:nvSpPr>
         <p:spPr>
           <a:xfrm>
-            <a:off x="1069848" y="3950208"/>
+            <a:off x="1069848" y="3639312"/>
             <a:ext cx="3200400" cy="274320"/>
           </a:xfrm>
           <a:prstGeom prst="rect">
@@ -8794,7 +8794,7 @@
               <a:buNone/>
             </a:pPr>
             <a:r>
-              <a:rPr lang="en-US" sz="1350" b="1" dirty="0">
+              <a:rPr lang="en-US" sz="1250" b="1" dirty="0">
                 <a:solidFill>
                   <a:srgbClr val="FFFFFF"/>
                 </a:solidFill>
@@ -8804,7 +8804,7 @@
               </a:rPr>
               <a:t>One RNG served lab and optimizer</a:t>
             </a:r>
-            <a:endParaRPr lang="en-US" sz="1350" dirty="0"/>
+            <a:endParaRPr lang="en-US" sz="1250" dirty="0"/>
           </a:p>
         </p:txBody>
       </p:sp>
@@ -8816,8 +8816,8 @@
         </p:nvSpPr>
         <p:spPr>
           <a:xfrm>
-            <a:off x="4361688" y="3913632"/>
-            <a:ext cx="3474720" cy="822960"/>
+            <a:off x="4361688" y="3602736"/>
+            <a:ext cx="3474720" cy="713232"/>
           </a:xfrm>
           <a:prstGeom prst="rect">
             <a:avLst/>
@@ -8831,12 +8831,12 @@
           <a:p>
             <a:pPr indent="0" marL="0">
               <a:lnSpc>
-                <a:spcPts val="1250"/>
+                <a:spcPts val="1200"/>
               </a:lnSpc>
               <a:buNone/>
             </a:pPr>
             <a:r>
-              <a:rPr lang="en-US" sz="950" dirty="0">
+              <a:rPr lang="en-US" sz="900" dirty="0">
                 <a:solidFill>
                   <a:srgbClr val="9CACBA"/>
                 </a:solidFill>
@@ -8846,7 +8846,7 @@
               </a:rPr>
               <a:t>BO draws ~512 candidates per iteration, random search draws 5 — so the two methods faced different measurement noise. The per-seed comparison was meaningless.</a:t>
             </a:r>
-            <a:endParaRPr lang="en-US" sz="950" dirty="0"/>
+            <a:endParaRPr lang="en-US" sz="900" dirty="0"/>
           </a:p>
         </p:txBody>
       </p:sp>
@@ -8858,8 +8858,8 @@
         </p:nvSpPr>
         <p:spPr>
           <a:xfrm>
-            <a:off x="8138160" y="3913632"/>
-            <a:ext cx="3474720" cy="822960"/>
+            <a:off x="8138160" y="3602736"/>
+            <a:ext cx="3474720" cy="713232"/>
           </a:xfrm>
           <a:prstGeom prst="rect">
             <a:avLst/>
@@ -8873,12 +8873,12 @@
           <a:p>
             <a:pPr indent="0" marL="0">
               <a:lnSpc>
-                <a:spcPts val="1250"/>
+                <a:spcPts val="1200"/>
               </a:lnSpc>
               <a:buNone/>
             </a:pPr>
             <a:r>
-              <a:rPr lang="en-US" sz="950" i="1" dirty="0">
+              <a:rPr lang="en-US" sz="900" i="1" dirty="0">
                 <a:solidFill>
                   <a:srgbClr val="6FA8CE"/>
                 </a:solidFill>
@@ -8888,7 +8888,7 @@
               </a:rPr>
               <a:t>Separate streams, and common random numbers across methods.</a:t>
             </a:r>
-            <a:endParaRPr lang="en-US" sz="950" dirty="0"/>
+            <a:endParaRPr lang="en-US" sz="900" dirty="0"/>
           </a:p>
         </p:txBody>
       </p:sp>
@@ -8900,7 +8900,7 @@
         </p:nvSpPr>
         <p:spPr>
           <a:xfrm>
-            <a:off x="566928" y="4818888"/>
+            <a:off x="566928" y="4379976"/>
             <a:ext cx="457200" cy="274320"/>
           </a:xfrm>
           <a:prstGeom prst="rect">
@@ -8917,7 +8917,7 @@
               <a:buNone/>
             </a:pPr>
             <a:r>
-              <a:rPr lang="en-US" sz="1200" b="1" dirty="0">
+              <a:rPr lang="en-US" sz="1150" b="1" dirty="0">
                 <a:solidFill>
                   <a:srgbClr val="C2410C"/>
                 </a:solidFill>
@@ -8927,7 +8927,7 @@
               </a:rPr>
               <a:t>04</a:t>
             </a:r>
-            <a:endParaRPr lang="en-US" sz="1200" dirty="0"/>
+            <a:endParaRPr lang="en-US" sz="1150" dirty="0"/>
           </a:p>
         </p:txBody>
       </p:sp>
@@ -8939,7 +8939,7 @@
         </p:nvSpPr>
         <p:spPr>
           <a:xfrm>
-            <a:off x="1069848" y="4818888"/>
+            <a:off x="1069848" y="4379976"/>
             <a:ext cx="3200400" cy="274320"/>
           </a:xfrm>
           <a:prstGeom prst="rect">
@@ -8956,7 +8956,7 @@
               <a:buNone/>
             </a:pPr>
             <a:r>
-              <a:rPr lang="en-US" sz="1350" b="1" dirty="0">
+              <a:rPr lang="en-US" sz="1250" b="1" dirty="0">
                 <a:solidFill>
                   <a:srgbClr val="FFFFFF"/>
                 </a:solidFill>
@@ -8966,7 +8966,7 @@
               </a:rPr>
               <a:t>BO got trapped in failure regions</a:t>
             </a:r>
-            <a:endParaRPr lang="en-US" sz="1350" dirty="0"/>
+            <a:endParaRPr lang="en-US" sz="1250" dirty="0"/>
           </a:p>
         </p:txBody>
       </p:sp>
@@ -8978,8 +8978,8 @@
         </p:nvSpPr>
         <p:spPr>
           <a:xfrm>
-            <a:off x="4361688" y="4782312"/>
-            <a:ext cx="3474720" cy="822960"/>
+            <a:off x="4361688" y="4343400"/>
+            <a:ext cx="3474720" cy="713232"/>
           </a:xfrm>
           <a:prstGeom prst="rect">
             <a:avLst/>
@@ -8993,12 +8993,12 @@
           <a:p>
             <a:pPr indent="0" marL="0">
               <a:lnSpc>
-                <a:spcPts val="1250"/>
+                <a:spcPts val="1200"/>
               </a:lnSpc>
               <a:buNone/>
             </a:pPr>
             <a:r>
-              <a:rPr lang="en-US" sz="950" dirty="0">
+              <a:rPr lang="en-US" sz="900" dirty="0">
                 <a:solidFill>
                   <a:srgbClr val="9CACBA"/>
                 </a:solidFill>
@@ -9008,7 +9008,7 @@
               </a:rPr>
               <a:t>Failed experiments yield no objective, so a naive surrogate never learns to avoid them and keeps re-proposing into the dead zone, burning budget.</a:t>
             </a:r>
-            <a:endParaRPr lang="en-US" sz="950" dirty="0"/>
+            <a:endParaRPr lang="en-US" sz="900" dirty="0"/>
           </a:p>
         </p:txBody>
       </p:sp>
@@ -9020,8 +9020,8 @@
         </p:nvSpPr>
         <p:spPr>
           <a:xfrm>
-            <a:off x="8138160" y="4782312"/>
-            <a:ext cx="3474720" cy="822960"/>
+            <a:off x="8138160" y="4343400"/>
+            <a:ext cx="3474720" cy="713232"/>
           </a:xfrm>
           <a:prstGeom prst="rect">
             <a:avLst/>
@@ -9035,12 +9035,12 @@
           <a:p>
             <a:pPr indent="0" marL="0">
               <a:lnSpc>
-                <a:spcPts val="1250"/>
+                <a:spcPts val="1200"/>
               </a:lnSpc>
               <a:buNone/>
             </a:pPr>
             <a:r>
-              <a:rPr lang="en-US" sz="950" i="1" dirty="0">
+              <a:rPr lang="en-US" sz="900" i="1" dirty="0">
                 <a:solidFill>
                   <a:srgbClr val="6FA8CE"/>
                 </a:solidFill>
@@ -9050,7 +9050,7 @@
               </a:rPr>
               <a:t>A feasibility penalty and an escape hatch — a real constrained-BO problem.</a:t>
             </a:r>
-            <a:endParaRPr lang="en-US" sz="950" dirty="0"/>
+            <a:endParaRPr lang="en-US" sz="900" dirty="0"/>
           </a:p>
         </p:txBody>
       </p:sp>
@@ -9062,7 +9062,7 @@
         </p:nvSpPr>
         <p:spPr>
           <a:xfrm>
-            <a:off x="566928" y="5687568"/>
+            <a:off x="566928" y="5120640"/>
             <a:ext cx="457200" cy="274320"/>
           </a:xfrm>
           <a:prstGeom prst="rect">
@@ -9079,7 +9079,7 @@
               <a:buNone/>
             </a:pPr>
             <a:r>
-              <a:rPr lang="en-US" sz="1200" b="1" dirty="0">
+              <a:rPr lang="en-US" sz="1150" b="1" dirty="0">
                 <a:solidFill>
                   <a:srgbClr val="C2410C"/>
                 </a:solidFill>
@@ -9089,7 +9089,7 @@
               </a:rPr>
               <a:t>05</a:t>
             </a:r>
-            <a:endParaRPr lang="en-US" sz="1200" dirty="0"/>
+            <a:endParaRPr lang="en-US" sz="1150" dirty="0"/>
           </a:p>
         </p:txBody>
       </p:sp>
@@ -9101,7 +9101,7 @@
         </p:nvSpPr>
         <p:spPr>
           <a:xfrm>
-            <a:off x="1069848" y="5687568"/>
+            <a:off x="1069848" y="5120640"/>
             <a:ext cx="3200400" cy="274320"/>
           </a:xfrm>
           <a:prstGeom prst="rect">
@@ -9118,7 +9118,7 @@
               <a:buNone/>
             </a:pPr>
             <a:r>
-              <a:rPr lang="en-US" sz="1350" b="1" dirty="0">
+              <a:rPr lang="en-US" sz="1250" b="1" dirty="0">
                 <a:solidFill>
                   <a:srgbClr val="FFFFFF"/>
                 </a:solidFill>
@@ -9128,7 +9128,7 @@
               </a:rPr>
               <a:t>Rounding moved the median by 0.006</a:t>
             </a:r>
-            <a:endParaRPr lang="en-US" sz="1350" dirty="0"/>
+            <a:endParaRPr lang="en-US" sz="1250" dirty="0"/>
           </a:p>
         </p:txBody>
       </p:sp>
@@ -9140,8 +9140,8 @@
         </p:nvSpPr>
         <p:spPr>
           <a:xfrm>
-            <a:off x="4361688" y="5650992"/>
-            <a:ext cx="3474720" cy="822960"/>
+            <a:off x="4361688" y="5084064"/>
+            <a:ext cx="3474720" cy="713232"/>
           </a:xfrm>
           <a:prstGeom prst="rect">
             <a:avLst/>
@@ -9155,12 +9155,12 @@
           <a:p>
             <a:pPr indent="0" marL="0">
               <a:lnSpc>
-                <a:spcPts val="1250"/>
+                <a:spcPts val="1200"/>
               </a:lnSpc>
               <a:buNone/>
             </a:pPr>
             <a:r>
-              <a:rPr lang="en-US" sz="950" dirty="0">
+              <a:rPr lang="en-US" sz="900" dirty="0">
                 <a:solidFill>
                   <a:srgbClr val="9CACBA"/>
                 </a:solidFill>
@@ -9170,7 +9170,7 @@
               </a:rPr>
               <a:t>Rounding each weighted term to six decimals — a 1e-4 perturbation — changed which point the GP held as incumbent, changed the argmax of Expected Improvement, and redirected the whole search.</a:t>
             </a:r>
-            <a:endParaRPr lang="en-US" sz="950" dirty="0"/>
+            <a:endParaRPr lang="en-US" sz="900" dirty="0"/>
           </a:p>
         </p:txBody>
       </p:sp>
@@ -9182,8 +9182,8 @@
         </p:nvSpPr>
         <p:spPr>
           <a:xfrm>
-            <a:off x="8138160" y="5650992"/>
-            <a:ext cx="3474720" cy="822960"/>
+            <a:off x="8138160" y="5084064"/>
+            <a:ext cx="3474720" cy="713232"/>
           </a:xfrm>
           <a:prstGeom prst="rect">
             <a:avLst/>
@@ -9197,12 +9197,12 @@
           <a:p>
             <a:pPr indent="0" marL="0">
               <a:lnSpc>
-                <a:spcPts val="1250"/>
+                <a:spcPts val="1200"/>
               </a:lnSpc>
               <a:buNone/>
             </a:pPr>
             <a:r>
-              <a:rPr lang="en-US" sz="950" i="1" dirty="0">
+              <a:rPr lang="en-US" sz="900" i="1" dirty="0">
                 <a:solidFill>
                   <a:srgbClr val="6FA8CE"/>
                 </a:solidFill>
@@ -9212,7 +9212,169 @@
               </a:rPr>
               <a:t>Closed loops are chaotically sensitive to their own numerics. Round for display, never before a decision.</a:t>
             </a:r>
-            <a:endParaRPr lang="en-US" sz="950" dirty="0"/>
+            <a:endParaRPr lang="en-US" sz="900" dirty="0"/>
+          </a:p>
+        </p:txBody>
+      </p:sp>
+      <p:sp>
+        <p:nvSpPr>
+          <p:cNvPr id="26" name="Text 24"/>
+          <p:cNvSpPr txBox="1"/>
+          <p:nvPr/>
+        </p:nvSpPr>
+        <p:spPr>
+          <a:xfrm>
+            <a:off x="566928" y="5861304"/>
+            <a:ext cx="457200" cy="274320"/>
+          </a:xfrm>
+          <a:prstGeom prst="rect">
+            <a:avLst/>
+          </a:prstGeom>
+          <a:noFill/>
+          <a:ln/>
+        </p:spPr>
+        <p:txBody>
+          <a:bodyPr wrap="square" lIns="0" tIns="0" rIns="0" bIns="0" rtlCol="0" anchor="ctr"/>
+          <a:lstStyle/>
+          <a:p>
+            <a:pPr indent="0" marL="0">
+              <a:buNone/>
+            </a:pPr>
+            <a:r>
+              <a:rPr lang="en-US" sz="1150" b="1" dirty="0">
+                <a:solidFill>
+                  <a:srgbClr val="C2410C"/>
+                </a:solidFill>
+                <a:latin typeface="Courier New" pitchFamily="34" charset="0"/>
+                <a:ea typeface="Courier New" pitchFamily="34" charset="-122"/>
+                <a:cs typeface="Courier New" pitchFamily="34" charset="-120"/>
+              </a:rPr>
+              <a:t>06</a:t>
+            </a:r>
+            <a:endParaRPr lang="en-US" sz="1150" dirty="0"/>
+          </a:p>
+        </p:txBody>
+      </p:sp>
+      <p:sp>
+        <p:nvSpPr>
+          <p:cNvPr id="27" name="Text 25"/>
+          <p:cNvSpPr txBox="1"/>
+          <p:nvPr/>
+        </p:nvSpPr>
+        <p:spPr>
+          <a:xfrm>
+            <a:off x="1069848" y="5861304"/>
+            <a:ext cx="3200400" cy="274320"/>
+          </a:xfrm>
+          <a:prstGeom prst="rect">
+            <a:avLst/>
+          </a:prstGeom>
+          <a:noFill/>
+          <a:ln/>
+        </p:spPr>
+        <p:txBody>
+          <a:bodyPr wrap="square" lIns="0" tIns="0" rIns="0" bIns="0" rtlCol="0" anchor="ctr"/>
+          <a:lstStyle/>
+          <a:p>
+            <a:pPr indent="0" marL="0">
+              <a:buNone/>
+            </a:pPr>
+            <a:r>
+              <a:rPr lang="en-US" sz="1250" b="1" dirty="0">
+                <a:solidFill>
+                  <a:srgbClr val="FFFFFF"/>
+                </a:solidFill>
+                <a:latin typeface="Cambria" pitchFamily="34" charset="0"/>
+                <a:ea typeface="Cambria" pitchFamily="34" charset="-122"/>
+                <a:cs typeface="Cambria" pitchFamily="34" charset="-120"/>
+              </a:rPr>
+              <a:t>Fabricated data labelled as published</a:t>
+            </a:r>
+            <a:endParaRPr lang="en-US" sz="1250" dirty="0"/>
+          </a:p>
+        </p:txBody>
+      </p:sp>
+      <p:sp>
+        <p:nvSpPr>
+          <p:cNvPr id="28" name="Text 26"/>
+          <p:cNvSpPr txBox="1"/>
+          <p:nvPr/>
+        </p:nvSpPr>
+        <p:spPr>
+          <a:xfrm>
+            <a:off x="4361688" y="5824728"/>
+            <a:ext cx="3474720" cy="713232"/>
+          </a:xfrm>
+          <a:prstGeom prst="rect">
+            <a:avLst/>
+          </a:prstGeom>
+          <a:noFill/>
+          <a:ln/>
+        </p:spPr>
+        <p:txBody>
+          <a:bodyPr wrap="square" lIns="0" tIns="0" rIns="0" bIns="0" rtlCol="0" anchor="t"/>
+          <a:lstStyle/>
+          <a:p>
+            <a:pPr indent="0" marL="0">
+              <a:lnSpc>
+                <a:spcPts val="1200"/>
+              </a:lnSpc>
+              <a:buNone/>
+            </a:pPr>
+            <a:r>
+              <a:rPr lang="en-US" sz="900" dirty="0">
+                <a:solidFill>
+                  <a:srgbClr val="9CACBA"/>
+                </a:solidFill>
+                <a:latin typeface="Calibri" pitchFamily="34" charset="0"/>
+                <a:ea typeface="Calibri" pitchFamily="34" charset="-122"/>
+                <a:cs typeface="Calibri" pitchFamily="34" charset="-120"/>
+              </a:rPr>
+              <a:t>An earlier version shipped a 25-row hydride dataset whose header said the values came straight from the paper. Three compounds in it appear nowhere in that paper. Invented numbers, presented as measurements.</a:t>
+            </a:r>
+            <a:endParaRPr lang="en-US" sz="900" dirty="0"/>
+          </a:p>
+        </p:txBody>
+      </p:sp>
+      <p:sp>
+        <p:nvSpPr>
+          <p:cNvPr id="29" name="Text 27"/>
+          <p:cNvSpPr txBox="1"/>
+          <p:nvPr/>
+        </p:nvSpPr>
+        <p:spPr>
+          <a:xfrm>
+            <a:off x="8138160" y="5824728"/>
+            <a:ext cx="3474720" cy="713232"/>
+          </a:xfrm>
+          <a:prstGeom prst="rect">
+            <a:avLst/>
+          </a:prstGeom>
+          <a:noFill/>
+          <a:ln/>
+        </p:spPr>
+        <p:txBody>
+          <a:bodyPr wrap="square" lIns="0" tIns="0" rIns="0" bIns="0" rtlCol="0" anchor="t"/>
+          <a:lstStyle/>
+          <a:p>
+            <a:pPr indent="0" marL="0">
+              <a:lnSpc>
+                <a:spcPts val="1200"/>
+              </a:lnSpc>
+              <a:buNone/>
+            </a:pPr>
+            <a:r>
+              <a:rPr lang="en-US" sz="900" i="1" dirty="0">
+                <a:solidFill>
+                  <a:srgbClr val="6FA8CE"/>
+                </a:solidFill>
+                <a:latin typeface="Calibri" pitchFamily="34" charset="0"/>
+                <a:ea typeface="Calibri" pitchFamily="34" charset="-122"/>
+                <a:cs typeface="Calibri" pitchFamily="34" charset="-120"/>
+              </a:rPr>
+              <a:t>A fabricated row is indistinguishable from a transcribed one once they share a file. Provenance has to be a boundary, not a comment.</a:t>
+            </a:r>
+            <a:endParaRPr lang="en-US" sz="900" dirty="0"/>
           </a:p>
         </p:txBody>
       </p:sp>

</xml_diff>